<commit_message>
Atualiza link do repositório na apresentação e no README
</commit_message>
<xml_diff>
--- a/docs/apresentacao.pptx
+++ b/docs/apresentacao.pptx
@@ -124,51 +124,51 @@
   <p:extLst>
     <p:ext uri="{521415D9-36F7-43E2-AB2F-B90AF26B5E84}">
       <p14:sectionLst xmlns:p14="http://schemas.microsoft.com/office/powerpoint/2010/main">
-        <p14:section name="Abertura" id="{c10a7d27-9aa3-88bc-1d2f-4e8616591ed0}">
+        <p14:section name="Abertura" id="{de76992d-4460-ad31-a920-82c3c7abae36}">
           <p14:sldIdLst>
             <p14:sldId id="256"/>
           </p14:sldIdLst>
         </p14:section>
-        <p14:section name="1. A proposta" id="{956c5e20-660e-cd9c-58de-7a1b6499c3e1}">
+        <p14:section name="1. A proposta" id="{9ef3b6c7-99bb-c3f0-df68-5450ece24326}">
           <p14:sldIdLst>
             <p14:sldId id="257"/>
           </p14:sldIdLst>
         </p14:section>
-        <p14:section name="2. O desafio técnico" id="{ff2ead68-22d2-ba5d-9cbc-0f5114f01a21}">
+        <p14:section name="2. O desafio técnico" id="{909a32f9-23a2-6c42-d60d-6c94000b901e}">
           <p14:sldIdLst>
             <p14:sldId id="258"/>
           </p14:sldIdLst>
         </p14:section>
-        <p14:section name="3. A solução desenvolvida" id="{a40638ea-b768-d382-9b19-4ec5788d7013}">
+        <p14:section name="3. A solução desenvolvida" id="{9b7d8f4d-3d74-cc20-9be0-12531c29960c}">
           <p14:sldIdLst>
             <p14:sldId id="259"/>
             <p14:sldId id="260"/>
           </p14:sldIdLst>
         </p14:section>
-        <p14:section name="4. Árvore AVL" id="{db35e868-f37a-6543-627f-998a2d281c7c}">
+        <p14:section name="4. Árvore AVL" id="{6d0b6e61-b4f9-db04-bd74-54d9602947c0}">
           <p14:sldIdLst>
             <p14:sldId id="261"/>
             <p14:sldId id="262"/>
           </p14:sldIdLst>
         </p14:section>
-        <p14:section name="5. Árvore Rubro-Negra" id="{77d8a8c5-acc2-1250-c307-46b4bdf4144d}">
+        <p14:section name="5. Árvore Rubro-Negra" id="{f65befea-e510-ab36-6303-8123088f8db1}">
           <p14:sldIdLst>
             <p14:sldId id="263"/>
             <p14:sldId id="264"/>
           </p14:sldIdLst>
         </p14:section>
-        <p14:section name="6. Demonstração" id="{21875304-7e9c-a09d-15c8-865bbad19bea}">
+        <p14:section name="6. Demonstração" id="{96ab7ee9-9147-9953-d9b7-630011f54ff1}">
           <p14:sldIdLst>
             <p14:sldId id="265"/>
             <p14:sldId id="266"/>
           </p14:sldIdLst>
         </p14:section>
-        <p14:section name="7. Testes realizados" id="{0ebe7122-7324-7b5a-7daf-1eb8b8dd8b6b}">
+        <p14:section name="7. Testes realizados" id="{ee5c80cc-c2fd-76ef-657c-046a6fc537a3}">
           <p14:sldIdLst>
             <p14:sldId id="267"/>
           </p14:sldIdLst>
         </p14:section>
-        <p14:section name="8. Análise comparativa" id="{674a8e09-e7f5-4aef-8e37-6761cc3fc3b8}">
+        <p14:section name="8. Análise comparativa" id="{3c30b480-b0fa-a7ca-d6ff-e2a8e6b18c24}">
           <p14:sldIdLst>
             <p14:sldId id="268"/>
             <p14:sldId id="269"/>
@@ -176,12 +176,12 @@
             <p14:sldId id="271"/>
           </p14:sldIdLst>
         </p14:section>
-        <p14:section name="9. Recomendação técnica" id="{f5ce3624-2dbb-e10a-a833-888301d46e64}">
+        <p14:section name="9. Recomendação técnica" id="{7437e5e0-7bea-af5e-2bdf-f3bc8468b255}">
           <p14:sldIdLst>
             <p14:sldId id="272"/>
           </p14:sldIdLst>
         </p14:section>
-        <p14:section name="10. Referências e repositório" id="{7874b2a6-1991-b4a7-a4c8-bce3c8e343b4}">
+        <p14:section name="10. Referências e repositório" id="{8f9d3491-aba5-cd57-0e5a-6da263a8d56f}">
           <p14:sldIdLst>
             <p14:sldId id="273"/>
           </p14:sldIdLst>
@@ -13444,7 +13444,7 @@
                   </a:extLst>
                 </a:hlinkClick>
               </a:rPr>
-              <a:t>github.com/SEU-USUARIO/arvores-balanceadas</a:t>
+              <a:t>github.com/LeoRosendof/Sistema-de-Arvores</a:t>
             </a:r>
             <a:endParaRPr lang="en-US" sz="1600" dirty="0"/>
           </a:p>

</xml_diff>

<commit_message>
Corrige imprecisões na apresentação e no README
- Slide 11: inclui o passo "Remoção caso 1 (irmão 25 vermelho)" ao remover 40,
  conforme o registro em docs/evidencias/demo_rubro_negra.txt
- Slide 16: limite da Rubro-Negra como 2·log2(n+1) e inserção da AVL 17–40% mais lenta
- Slide 17: com chaves aleatórias a Rubro-Negra inseriu cerca de 15% mais rápido
- README: remove menção a gráficos inexistentes em docs/ e ajusta o percentual

Co-Authored-By: Claude Opus 5.5 <noreply@anthropic.com>
</commit_message>
<xml_diff>
--- a/docs/apresentacao.pptx
+++ b/docs/apresentacao.pptx
@@ -6765,6 +6765,23 @@
                 <a:ea typeface="Courier New" pitchFamily="34" charset="-122"/>
                 <a:cs typeface="Courier New" pitchFamily="34" charset="-120"/>
               </a:rPr>
+              <a:t>  &gt; Remoção caso 1 (irmão 25 vermelho): recolorir e rotacionar no pai 50</a:t>
+            </a:r>
+            <a:endParaRPr lang="en-US" sz="1050" dirty="0"/>
+          </a:p>
+          <a:p>
+            <a:pPr indent="0" marL="0">
+              <a:buNone/>
+            </a:pPr>
+            <a:r>
+              <a:rPr lang="en-US" sz="1050" dirty="0">
+                <a:solidFill>
+                  <a:srgbClr val="7BC96F"/>
+                </a:solidFill>
+                <a:latin typeface="Courier New" pitchFamily="34" charset="0"/>
+                <a:ea typeface="Courier New" pitchFamily="34" charset="-122"/>
+                <a:cs typeface="Courier New" pitchFamily="34" charset="-120"/>
+              </a:rPr>
               <a:t>  &gt; Remoção caso 2 (irmão 30 preto, sobrinhos pretos): irmão fica vermelho, sobe para 50</a:t>
             </a:r>
             <a:endParaRPr lang="en-US" sz="1050" dirty="0"/>
@@ -12311,7 +12328,7 @@
                   <a:srgbClr val="1B1F24"/>
                 </a:solidFill>
               </a:rPr>
-              <a:t>atualiza alturas no caminho todo; remoção pode rotacionar em vários níveis; inserção 15–28% mais lenta</a:t>
+              <a:t>atualiza alturas no caminho todo; remoção pode rotacionar em vários níveis; inserção 17–40% mais lenta</a:t>
             </a:r>
             <a:endParaRPr lang="en-US" sz="1550" dirty="0"/>
           </a:p>
@@ -12485,7 +12502,7 @@
                   <a:srgbClr val="1B1F24"/>
                 </a:solidFill>
               </a:rPr>
-              <a:t>balanceamento frouxo por cores (h ≤ 2 log₂ n)</a:t>
+              <a:t>balanceamento frouxo por cores (h ≤ 2 log₂(n + 1))</a:t>
             </a:r>
             <a:endParaRPr lang="en-US" sz="1550" dirty="0"/>
           </a:p>
@@ -13166,7 +13183,7 @@
                   <a:srgbClr val="1B1F24"/>
                 </a:solidFill>
               </a:rPr>
-              <a:t>chaves em ordem aleatória com escrita predominante, ou quando é preciso limitar a reestruturação por operação (estruturas concorrentes ou persistentes). Nesses casos ela fez 16% menos rotações e inseriu de 15% a 28% mais rápido nos testes.</a:t>
+              <a:t>chaves em ordem aleatória com escrita predominante, ou quando é preciso limitar a reestruturação por operação (estruturas concorrentes ou persistentes). Com chaves aleatórias, ela fez 16% menos rotações e inseriu cerca de 15% mais rápido nos testes.</a:t>
             </a:r>
             <a:endParaRPr lang="en-US" sz="1600" dirty="0"/>
           </a:p>

</xml_diff>

<commit_message>
Declara o uso de IA na apresentação (slide de referências)
Co-Authored-By: Claude Opus 5.5 <noreply@anthropic.com>
</commit_message>
<xml_diff>
--- a/docs/apresentacao.pptx
+++ b/docs/apresentacao.pptx
@@ -13642,7 +13642,7 @@
         <p:spPr>
           <a:xfrm>
             <a:off x="5852160" y="1828800"/>
-            <a:ext cx="5806440" cy="4251960"/>
+            <a:ext cx="5806440" cy="2743200"/>
           </a:xfrm>
           <a:prstGeom prst="rect">
             <a:avLst/>
@@ -13752,6 +13752,81 @@
                 </a:solidFill>
               </a:rPr>
               <a:t>SZWARCFITER, J. L.; MARKENZON, L. Estruturas de Dados e seus Algoritmos. 3. ed. LTC, 2010.</a:t>
+            </a:r>
+            <a:endParaRPr lang="en-US" sz="1300" dirty="0"/>
+          </a:p>
+        </p:txBody>
+      </p:sp>
+      <p:sp>
+        <p:nvSpPr>
+          <p:cNvPr id="26" name="Uso de IA - título"/>
+          <p:cNvSpPr txBox="1"/>
+          <p:nvPr/>
+        </p:nvSpPr>
+        <p:spPr>
+          <a:xfrm>
+            <a:off x="5852160" y="4663440"/>
+            <a:ext cx="5806440" cy="365760"/>
+          </a:xfrm>
+          <a:prstGeom prst="rect">
+            <a:avLst/>
+          </a:prstGeom>
+          <a:noFill/>
+          <a:ln/>
+        </p:spPr>
+        <p:txBody>
+          <a:bodyPr wrap="square" lIns="0" tIns="0" rIns="0" bIns="0" rtlCol="0" anchor="t"/>
+          <a:lstStyle/>
+          <a:p>
+            <a:pPr indent="0" marL="0">
+              <a:buNone/>
+            </a:pPr>
+            <a:r>
+              <a:rPr lang="en-US" sz="1800" b="1" dirty="0">
+                <a:solidFill>
+                  <a:srgbClr val="0F2A3A"/>
+                </a:solidFill>
+              </a:rPr>
+              <a:t>Uso de inteligência artificial</a:t>
+            </a:r>
+            <a:endParaRPr lang="en-US" sz="1800" dirty="0"/>
+          </a:p>
+        </p:txBody>
+      </p:sp>
+      <p:sp>
+        <p:nvSpPr>
+          <p:cNvPr id="27" name="Uso de IA - texto"/>
+          <p:cNvSpPr txBox="1"/>
+          <p:nvPr/>
+        </p:nvSpPr>
+        <p:spPr>
+          <a:xfrm>
+            <a:off x="5852160" y="5074920"/>
+            <a:ext cx="5806440" cy="1005840"/>
+          </a:xfrm>
+          <a:prstGeom prst="rect">
+            <a:avLst/>
+          </a:prstGeom>
+          <a:noFill/>
+          <a:ln/>
+        </p:spPr>
+        <p:txBody>
+          <a:bodyPr wrap="square" lIns="0" tIns="0" rIns="0" bIns="0" rtlCol="0" anchor="t"/>
+          <a:lstStyle/>
+          <a:p>
+            <a:pPr indent="0" marL="0">
+              <a:spcAft>
+                <a:spcPts val="900"/>
+              </a:spcAft>
+              <a:buNone/>
+            </a:pPr>
+            <a:r>
+              <a:rPr lang="en-US" sz="1300" dirty="0">
+                <a:solidFill>
+                  <a:srgbClr val="1B1F24"/>
+                </a:solidFill>
+              </a:rPr>
+              <a:t>Desenvolvido com apoio do Claude (Anthropic), assistente de IA usado na revisão do código e dos testes, na conferência dos resultados e em correções desta apresentação. Decisões, análise e recomendação são do autor; detalhes na seção 9 do README.</a:t>
             </a:r>
             <a:endParaRPr lang="en-US" sz="1300" dirty="0"/>
           </a:p>

</xml_diff>

<commit_message>
Adiciona o link do repositório na capa da apresentação
Co-Authored-By: Claude Opus 5.5 <noreply@anthropic.com>
</commit_message>
<xml_diff>
--- a/docs/apresentacao.pptx
+++ b/docs/apresentacao.pptx
@@ -4228,7 +4228,7 @@
         <p:spPr>
           <a:xfrm>
             <a:off x="731520" y="4526280"/>
-            <a:ext cx="6766560" cy="1005840"/>
+            <a:ext cx="6766560" cy="1463040"/>
           </a:xfrm>
           <a:prstGeom prst="rect">
             <a:avLst/>
@@ -4278,6 +4278,38 @@
                 </a:solidFill>
               </a:rPr>
               <a:t>Estruturas de Dados Básicas II  ·  UFRN/IMD  ·  Outubro de 2026</a:t>
+            </a:r>
+            <a:endParaRPr lang="en-US" sz="1500" dirty="0"/>
+          </a:p>
+          <a:p>
+            <a:pPr indent="0" marL="0">
+              <a:spcBef>
+                <a:spcPts val="1200"/>
+              </a:spcBef>
+              <a:buNone/>
+            </a:pPr>
+            <a:r>
+              <a:rPr lang="en-US" sz="1500" dirty="0">
+                <a:solidFill>
+                  <a:srgbClr val="CFE0EA"/>
+                </a:solidFill>
+              </a:rPr>
+              <a:t>Repositório: </a:t>
+            </a:r>
+            <a:r>
+              <a:rPr lang="en-US" sz="1500" b="1" u="sng" dirty="0">
+                <a:solidFill>
+                  <a:srgbClr val="F28C28"/>
+                </a:solidFill>
+                <a:hlinkClick r:id="rId3">
+                  <a:extLst>
+                    <a:ext uri="{A12FA001-AC4F-418D-AE19-62706E023703}">
+                      <ahyp:hlinkClr xmlns:ahyp="http://schemas.microsoft.com/office/drawing/2018/hyperlinkcolor" val="tx"/>
+                    </a:ext>
+                  </a:extLst>
+                </a:hlinkClick>
+              </a:rPr>
+              <a:t>https://github.com/LeoRosendof/Sistema-de-Arvores</a:t>
             </a:r>
             <a:endParaRPr lang="en-US" sz="1500" dirty="0"/>
           </a:p>

</xml_diff>